<commit_message>
System Design 101 (vi): sd-11-037 qualify the Spot interruption notice in lesson, metadata and deck
Co-Authored-By: Claude Sonnet 5.5 <noreply@anthropic.com>
Claude-Session: https://claude.ai/code/session_01MF1cUkoXgxEMeDan8VPPYR
</commit_message>
<xml_diff>
--- a/system-design-101/vi/lessons/sd-11-037/slides/sd-11-037.pptx
+++ b/system-design-101/vi/lessons/sd-11-037/slides/sd-11-037.pptx
@@ -6854,7 +6854,7 @@
               <a:t> báo</a:t>
             </a:r>
             <a:r>
-              <a:rPr lang="en-US" sz="3150" b="1" dirty="0" spc="-4" kern="0">
+              <a:rPr lang="en-US" sz="3150" b="1" dirty="0" spc="-10" kern="0">
                 <a:solidFill>
                   <a:srgbClr val="F3EEE3"/>
                 </a:solidFill>
@@ -6862,7 +6862,7 @@
                 <a:ea typeface="Be Vietnam Pro" pitchFamily="34" charset="-122"/>
                 <a:cs typeface="Be Vietnam Pro" pitchFamily="34" charset="-120"/>
               </a:rPr>
-              <a:t> hai</a:t>
+              <a:t> không</a:t>
             </a:r>
             <a:r>
               <a:rPr lang="en-US" sz="3150" b="1" dirty="0" spc="1" kern="0">
@@ -6873,7 +6873,18 @@
                 <a:ea typeface="Be Vietnam Pro" pitchFamily="34" charset="-122"/>
                 <a:cs typeface="Be Vietnam Pro" pitchFamily="34" charset="-120"/>
               </a:rPr>
-              <a:t> phút.</a:t>
+              <a:t> bảo</a:t>
+            </a:r>
+            <a:r>
+              <a:rPr lang="en-US" sz="3150" b="1" dirty="0" spc="9" kern="0">
+                <a:solidFill>
+                  <a:srgbClr val="F3EEE3"/>
+                </a:solidFill>
+                <a:latin typeface="Be Vietnam Pro" pitchFamily="34" charset="0"/>
+                <a:ea typeface="Be Vietnam Pro" pitchFamily="34" charset="-122"/>
+                <a:cs typeface="Be Vietnam Pro" pitchFamily="34" charset="-120"/>
+              </a:rPr>
+              <a:t> đảm.</a:t>
             </a:r>
             <a:endParaRPr lang="en-US" sz="3150" dirty="0"/>
           </a:p>

</xml_diff>